<commit_message>
Fix name and remove unverified claims
- Correct author name: Hithesh Vurukonda → Hithesh Rai Purushothama
- Remove fabricated NVIDIA 98.5% accuracy claim (no source)
- Remove fabricated +5–8% few-shot benchmark comparison (no source)
- Replace with actual measured results from this project
</commit_message>
<xml_diff>
--- a/presentation/slides.pptx
+++ b/presentation/slides.pptx
@@ -3290,7 +3290,7 @@
                   <a:srgbClr val="CCE5FF"/>
                 </a:solidFill>
               </a:rPr>
-              <a:t>Hithesh Vurukonda  ·  March 2026</a:t>
+              <a:t>Hithesh Rai Purushothama  ·  March 2026</a:t>
             </a:r>
           </a:p>
         </p:txBody>
@@ -21652,7 +21652,7 @@
                   <a:srgbClr val="333333"/>
                 </a:solidFill>
               </a:rPr>
-              <a:t>Few-shot defect benchmarks</a:t>
+              <a:t>Cosine similarity alignment</a:t>
             </a:r>
           </a:p>
         </p:txBody>
@@ -21729,7 +21729,7 @@
                   <a:srgbClr val="333333"/>
                 </a:solidFill>
               </a:rPr>
-              <a:t>Baseline</a:t>
+              <a:t>Partial</a:t>
             </a:r>
           </a:p>
         </p:txBody>
@@ -21806,7 +21806,7 @@
                   <a:srgbClr val="333333"/>
                 </a:solidFill>
               </a:rPr>
-              <a:t>+5–8% bal. acc.</a:t>
+              <a:t>Direct</a:t>
             </a:r>
           </a:p>
         </p:txBody>
@@ -21883,7 +21883,7 @@
                   <a:srgbClr val="333333"/>
                 </a:solidFill>
               </a:rPr>
-              <a:t>Cosine similarity alignment</a:t>
+              <a:t>Cascade bal. acc. (this work)</a:t>
             </a:r>
           </a:p>
         </p:txBody>
@@ -21960,7 +21960,7 @@
                   <a:srgbClr val="333333"/>
                 </a:solidFill>
               </a:rPr>
-              <a:t>Partial</a:t>
+              <a:t>0.781 (EfficientNet)</a:t>
             </a:r>
           </a:p>
         </p:txBody>
@@ -22037,252 +22037,21 @@
                   <a:srgbClr val="333333"/>
                 </a:solidFill>
               </a:rPr>
-              <a:t>Direct</a:t>
-            </a:r>
-          </a:p>
-        </p:txBody>
-      </p:sp>
-      <p:sp>
-        <p:nvSpPr>
-          <p:cNvPr id="35" name="Rectangle 34"/>
-          <p:cNvSpPr/>
-          <p:nvPr/>
-        </p:nvSpPr>
-        <p:spPr>
-          <a:xfrm>
-            <a:off x="548640" y="3200400"/>
-            <a:ext cx="3474720" cy="338328"/>
-          </a:xfrm>
-          <a:prstGeom prst="rect">
-            <a:avLst/>
-          </a:prstGeom>
-          <a:solidFill>
-            <a:srgbClr val="F0F0F0"/>
-          </a:solidFill>
-          <a:ln>
-            <a:noFill/>
-          </a:ln>
-        </p:spPr>
-        <p:style>
-          <a:lnRef idx="1">
-            <a:schemeClr val="accent1"/>
-          </a:lnRef>
-          <a:fillRef idx="3">
-            <a:schemeClr val="accent1"/>
-          </a:fillRef>
-          <a:effectRef idx="2">
-            <a:schemeClr val="accent1"/>
-          </a:effectRef>
-          <a:fontRef idx="minor">
-            <a:schemeClr val="lt1"/>
-          </a:fontRef>
-        </p:style>
-        <p:txBody>
-          <a:bodyPr rtlCol="0" anchor="ctr"/>
-          <a:lstStyle/>
-          <a:p>
-            <a:pPr algn="ctr"/>
-          </a:p>
-        </p:txBody>
-      </p:sp>
-      <p:sp>
-        <p:nvSpPr>
-          <p:cNvPr id="36" name="TextBox 35"/>
-          <p:cNvSpPr txBox="1"/>
-          <p:nvPr/>
-        </p:nvSpPr>
-        <p:spPr>
-          <a:xfrm>
-            <a:off x="594360" y="3246120"/>
-            <a:ext cx="3383280" cy="292608"/>
-          </a:xfrm>
-          <a:prstGeom prst="rect">
-            <a:avLst/>
-          </a:prstGeom>
-          <a:noFill/>
-        </p:spPr>
-        <p:txBody>
-          <a:bodyPr wrap="square">
-            <a:spAutoFit/>
-          </a:bodyPr>
-          <a:lstStyle/>
-          <a:p>
-            <a:pPr algn="l"/>
-            <a:r>
-              <a:rPr sz="1400" b="0" i="0">
-                <a:solidFill>
-                  <a:srgbClr val="333333"/>
-                </a:solidFill>
-              </a:rPr>
-              <a:t>NVIDIA semiconductor AUC</a:t>
-            </a:r>
-          </a:p>
-        </p:txBody>
-      </p:sp>
-      <p:sp>
-        <p:nvSpPr>
-          <p:cNvPr id="37" name="Rectangle 36"/>
-          <p:cNvSpPr/>
-          <p:nvPr/>
-        </p:nvSpPr>
-        <p:spPr>
-          <a:xfrm>
-            <a:off x="4023360" y="3200400"/>
-            <a:ext cx="2926080" cy="338328"/>
-          </a:xfrm>
-          <a:prstGeom prst="rect">
-            <a:avLst/>
-          </a:prstGeom>
-          <a:solidFill>
-            <a:srgbClr val="F0F0F0"/>
-          </a:solidFill>
-          <a:ln>
-            <a:noFill/>
-          </a:ln>
-        </p:spPr>
-        <p:style>
-          <a:lnRef idx="1">
-            <a:schemeClr val="accent1"/>
-          </a:lnRef>
-          <a:fillRef idx="3">
-            <a:schemeClr val="accent1"/>
-          </a:fillRef>
-          <a:effectRef idx="2">
-            <a:schemeClr val="accent1"/>
-          </a:effectRef>
-          <a:fontRef idx="minor">
-            <a:schemeClr val="lt1"/>
-          </a:fontRef>
-        </p:style>
-        <p:txBody>
-          <a:bodyPr rtlCol="0" anchor="ctr"/>
-          <a:lstStyle/>
-          <a:p>
-            <a:pPr algn="ctr"/>
-          </a:p>
-        </p:txBody>
-      </p:sp>
-      <p:sp>
-        <p:nvSpPr>
-          <p:cNvPr id="38" name="TextBox 37"/>
-          <p:cNvSpPr txBox="1"/>
-          <p:nvPr/>
-        </p:nvSpPr>
-        <p:spPr>
-          <a:xfrm>
-            <a:off x="4069080" y="3246120"/>
-            <a:ext cx="2834640" cy="292608"/>
-          </a:xfrm>
-          <a:prstGeom prst="rect">
-            <a:avLst/>
-          </a:prstGeom>
-          <a:noFill/>
-        </p:spPr>
-        <p:txBody>
-          <a:bodyPr wrap="square">
-            <a:spAutoFit/>
-          </a:bodyPr>
-          <a:lstStyle/>
-          <a:p>
-            <a:pPr algn="l"/>
-            <a:r>
-              <a:rPr sz="1400" b="0" i="0">
-                <a:solidFill>
-                  <a:srgbClr val="333333"/>
-                </a:solidFill>
-              </a:rPr>
-              <a:t>—</a:t>
-            </a:r>
-          </a:p>
-        </p:txBody>
-      </p:sp>
-      <p:sp>
-        <p:nvSpPr>
-          <p:cNvPr id="39" name="Rectangle 38"/>
-          <p:cNvSpPr/>
-          <p:nvPr/>
-        </p:nvSpPr>
-        <p:spPr>
-          <a:xfrm>
-            <a:off x="6949440" y="3200400"/>
-            <a:ext cx="2926080" cy="338328"/>
-          </a:xfrm>
-          <a:prstGeom prst="rect">
-            <a:avLst/>
-          </a:prstGeom>
-          <a:solidFill>
-            <a:srgbClr val="F0F0F0"/>
-          </a:solidFill>
-          <a:ln>
-            <a:noFill/>
-          </a:ln>
-        </p:spPr>
-        <p:style>
-          <a:lnRef idx="1">
-            <a:schemeClr val="accent1"/>
-          </a:lnRef>
-          <a:fillRef idx="3">
-            <a:schemeClr val="accent1"/>
-          </a:fillRef>
-          <a:effectRef idx="2">
-            <a:schemeClr val="accent1"/>
-          </a:effectRef>
-          <a:fontRef idx="minor">
-            <a:schemeClr val="lt1"/>
-          </a:fontRef>
-        </p:style>
-        <p:txBody>
-          <a:bodyPr rtlCol="0" anchor="ctr"/>
-          <a:lstStyle/>
-          <a:p>
-            <a:pPr algn="ctr"/>
-          </a:p>
-        </p:txBody>
-      </p:sp>
-      <p:sp>
-        <p:nvSpPr>
-          <p:cNvPr id="40" name="TextBox 39"/>
-          <p:cNvSpPr txBox="1"/>
-          <p:nvPr/>
-        </p:nvSpPr>
-        <p:spPr>
-          <a:xfrm>
-            <a:off x="6995160" y="3246120"/>
-            <a:ext cx="2834640" cy="292608"/>
-          </a:xfrm>
-          <a:prstGeom prst="rect">
-            <a:avLst/>
-          </a:prstGeom>
-          <a:noFill/>
-        </p:spPr>
-        <p:txBody>
-          <a:bodyPr wrap="square">
-            <a:spAutoFit/>
-          </a:bodyPr>
-          <a:lstStyle/>
-          <a:p>
-            <a:pPr algn="l"/>
-            <a:r>
-              <a:rPr sz="1400" b="0" i="0">
-                <a:solidFill>
-                  <a:srgbClr val="333333"/>
-                </a:solidFill>
-              </a:rPr>
-              <a:t>98.5% die-level accuracy</a:t>
-            </a:r>
-          </a:p>
-        </p:txBody>
-      </p:sp>
-      <p:sp>
-        <p:nvSpPr>
-          <p:cNvPr id="41" name="TextBox 40"/>
-          <p:cNvSpPr txBox="1"/>
-          <p:nvPr/>
-        </p:nvSpPr>
-        <p:spPr>
-          <a:xfrm>
-            <a:off x="548640" y="3721608"/>
-            <a:ext cx="11091672" cy="2953512"/>
+              <a:t>0.909 (DINOv2)</a:t>
+            </a:r>
+          </a:p>
+        </p:txBody>
+      </p:sp>
+      <p:sp>
+        <p:nvSpPr>
+          <p:cNvPr id="35" name="TextBox 34"/>
+          <p:cNvSpPr txBox="1"/>
+          <p:nvPr/>
+        </p:nvSpPr>
+        <p:spPr>
+          <a:xfrm>
+            <a:off x="548640" y="3383280"/>
+            <a:ext cx="11091672" cy="3291840"/>
           </a:xfrm>
           <a:prstGeom prst="rect">
             <a:avLst/>

</xml_diff>